<commit_message>
add updated GNN and GAE lectures
</commit_message>
<xml_diff>
--- a/Lectures/07.GAE/Lecture_GAE_1.pptx
+++ b/Lectures/07.GAE/Lecture_GAE_1.pptx
@@ -8550,8 +8550,8 @@
           <a:chExt cx="0" cy="0"/>
         </a:xfrm>
       </p:grpSpPr>
-      <mc:AlternateContent xmlns:mc="http://schemas.openxmlformats.org/markup-compatibility/2006" xmlns:a14="http://schemas.microsoft.com/office/drawing/2010/main">
-        <mc:Choice Requires="a14">
+      <mc:AlternateContent xmlns:mc="http://schemas.openxmlformats.org/markup-compatibility/2006">
+        <mc:Choice xmlns:a14="http://schemas.microsoft.com/office/drawing/2010/main" Requires="a14">
           <p:sp>
             <p:nvSpPr>
               <p:cNvPr id="51" name="Content Placeholder 50">
@@ -8889,7 +8889,7 @@
                         </a:solidFill>
                         <a:latin typeface="Cambria Math" panose="02040503050406030204" pitchFamily="18" charset="0"/>
                       </a:rPr>
-                      <m:t>[0,  :] </m:t>
+                      <m:t>[0] </m:t>
                     </m:r>
                   </m:oMath>
                 </a14:m>
@@ -8944,7 +8944,25 @@
                         </a:solidFill>
                         <a:latin typeface="Cambria Math" panose="02040503050406030204" pitchFamily="18" charset="0"/>
                       </a:rPr>
-                      <m:t>[1,  :]</m:t>
+                      <m:t>[</m:t>
+                    </m:r>
+                    <m:r>
+                      <a:rPr lang="en-US" b="0" i="1" smtClean="0">
+                        <a:solidFill>
+                          <a:schemeClr val="tx1"/>
+                        </a:solidFill>
+                        <a:latin typeface="Cambria Math" panose="02040503050406030204" pitchFamily="18" charset="0"/>
+                      </a:rPr>
+                      <m:t>1</m:t>
+                    </m:r>
+                    <m:r>
+                      <a:rPr lang="en-US" b="0" i="1" smtClean="0">
+                        <a:solidFill>
+                          <a:schemeClr val="tx1"/>
+                        </a:solidFill>
+                        <a:latin typeface="Cambria Math" panose="02040503050406030204" pitchFamily="18" charset="0"/>
+                      </a:rPr>
+                      <m:t>]</m:t>
                     </m:r>
                   </m:oMath>
                 </a14:m>
@@ -8957,7 +8975,7 @@
             </p:txBody>
           </p:sp>
         </mc:Choice>
-        <mc:Fallback xmlns="">
+        <mc:Fallback>
           <p:sp>
             <p:nvSpPr>
               <p:cNvPr id="51" name="Content Placeholder 50">

</xml_diff>

<commit_message>
update a few lectures
</commit_message>
<xml_diff>
--- a/Lectures/07.GAE/Lecture_GAE_1.pptx
+++ b/Lectures/07.GAE/Lecture_GAE_1.pptx
@@ -8019,8 +8019,8 @@
           <a:chExt cx="0" cy="0"/>
         </a:xfrm>
       </p:grpSpPr>
-      <mc:AlternateContent xmlns:mc="http://schemas.openxmlformats.org/markup-compatibility/2006" xmlns:a14="http://schemas.microsoft.com/office/drawing/2010/main">
-        <mc:Choice Requires="a14">
+      <mc:AlternateContent xmlns:mc="http://schemas.openxmlformats.org/markup-compatibility/2006">
+        <mc:Choice xmlns:a14="http://schemas.microsoft.com/office/drawing/2010/main" Requires="a14">
           <p:sp>
             <p:nvSpPr>
               <p:cNvPr id="8" name="Content Placeholder 7">
@@ -8313,7 +8313,7 @@
                 </a:br>
                 <a:r>
                   <a:rPr lang="en-US" dirty="0"/>
-                  <a:t>a particle with </a:t>
+                  <a:t>particle with </a:t>
                 </a:r>
                 <a:r>
                   <a:rPr lang="en-US" dirty="0">
@@ -8325,8 +8325,69 @@
                 </a:r>
                 <a:r>
                   <a:rPr lang="en-US" dirty="0"/>
-                  <a:t>features.</a:t>
+                  <a:t>features, </a:t>
                 </a:r>
+                <a14:m>
+                  <m:oMath xmlns:m="http://schemas.openxmlformats.org/officeDocument/2006/math">
+                    <m:sSub>
+                      <m:sSubPr>
+                        <m:ctrlPr>
+                          <a:rPr lang="en-US" i="1">
+                            <a:latin typeface="Cambria Math" panose="02040503050406030204" pitchFamily="18" charset="0"/>
+                          </a:rPr>
+                        </m:ctrlPr>
+                      </m:sSubPr>
+                      <m:e>
+                        <m:r>
+                          <a:rPr lang="en-US" i="1">
+                            <a:latin typeface="Cambria Math" panose="02040503050406030204" pitchFamily="18" charset="0"/>
+                          </a:rPr>
+                          <m:t>𝑝</m:t>
+                        </m:r>
+                      </m:e>
+                      <m:sub>
+                        <m:r>
+                          <a:rPr lang="en-US" i="1">
+                            <a:latin typeface="Cambria Math" panose="02040503050406030204" pitchFamily="18" charset="0"/>
+                          </a:rPr>
+                          <m:t>𝑇</m:t>
+                        </m:r>
+                      </m:sub>
+                    </m:sSub>
+                    <m:r>
+                      <a:rPr lang="en-US" i="1">
+                        <a:latin typeface="Cambria Math" panose="02040503050406030204" pitchFamily="18" charset="0"/>
+                      </a:rPr>
+                      <m:t>, </m:t>
+                    </m:r>
+                    <m:r>
+                      <a:rPr lang="en-US" i="1">
+                        <a:latin typeface="Cambria Math" panose="02040503050406030204" pitchFamily="18" charset="0"/>
+                      </a:rPr>
+                      <m:t>𝜂</m:t>
+                    </m:r>
+                    <m:r>
+                      <a:rPr lang="en-US" i="1">
+                        <a:latin typeface="Cambria Math" panose="02040503050406030204" pitchFamily="18" charset="0"/>
+                      </a:rPr>
+                      <m:t>,</m:t>
+                    </m:r>
+                    <m:r>
+                      <a:rPr lang="en-US" b="0" i="1" smtClean="0">
+                        <a:latin typeface="Cambria Math" panose="02040503050406030204" pitchFamily="18" charset="0"/>
+                      </a:rPr>
+                      <m:t>𝜙</m:t>
+                    </m:r>
+                  </m:oMath>
+                </a14:m>
+                <a:r>
+                  <a:rPr lang="en-US" dirty="0"/>
+                  <a:t>.</a:t>
+                </a:r>
+                <a:br>
+                  <a:rPr lang="en-US" dirty="0"/>
+                </a:br>
+                <a:endParaRPr lang="en-US" dirty="0"/>
               </a:p>
               <a:p>
                 <a:endParaRPr lang="en-US" dirty="0"/>
@@ -8373,7 +8434,7 @@
             </p:txBody>
           </p:sp>
         </mc:Choice>
-        <mc:Fallback xmlns="">
+        <mc:Fallback>
           <p:sp>
             <p:nvSpPr>
               <p:cNvPr id="8" name="Content Placeholder 7">
@@ -8477,7 +8538,7 @@
         </p:blipFill>
         <p:spPr bwMode="auto">
           <a:xfrm>
-            <a:off x="5182001" y="3429000"/>
+            <a:off x="5334401" y="3429000"/>
             <a:ext cx="3809599" cy="2514600"/>
           </a:xfrm>
           <a:prstGeom prst="rect">
@@ -8550,8 +8611,8 @@
           <a:chExt cx="0" cy="0"/>
         </a:xfrm>
       </p:grpSpPr>
-      <mc:AlternateContent xmlns:mc="http://schemas.openxmlformats.org/markup-compatibility/2006">
-        <mc:Choice xmlns:a14="http://schemas.microsoft.com/office/drawing/2010/main" Requires="a14">
+      <mc:AlternateContent xmlns:mc="http://schemas.openxmlformats.org/markup-compatibility/2006" xmlns:a14="http://schemas.microsoft.com/office/drawing/2010/main">
+        <mc:Choice Requires="a14">
           <p:sp>
             <p:nvSpPr>
               <p:cNvPr id="51" name="Content Placeholder 50">
@@ -8944,25 +9005,7 @@
                         </a:solidFill>
                         <a:latin typeface="Cambria Math" panose="02040503050406030204" pitchFamily="18" charset="0"/>
                       </a:rPr>
-                      <m:t>[</m:t>
-                    </m:r>
-                    <m:r>
-                      <a:rPr lang="en-US" b="0" i="1" smtClean="0">
-                        <a:solidFill>
-                          <a:schemeClr val="tx1"/>
-                        </a:solidFill>
-                        <a:latin typeface="Cambria Math" panose="02040503050406030204" pitchFamily="18" charset="0"/>
-                      </a:rPr>
-                      <m:t>1</m:t>
-                    </m:r>
-                    <m:r>
-                      <a:rPr lang="en-US" b="0" i="1" smtClean="0">
-                        <a:solidFill>
-                          <a:schemeClr val="tx1"/>
-                        </a:solidFill>
-                        <a:latin typeface="Cambria Math" panose="02040503050406030204" pitchFamily="18" charset="0"/>
-                      </a:rPr>
-                      <m:t>]</m:t>
+                      <m:t>[1]</m:t>
                     </m:r>
                   </m:oMath>
                 </a14:m>
@@ -8975,7 +9018,7 @@
             </p:txBody>
           </p:sp>
         </mc:Choice>
-        <mc:Fallback>
+        <mc:Fallback xmlns="">
           <p:sp>
             <p:nvSpPr>
               <p:cNvPr id="51" name="Content Placeholder 50">
@@ -10683,8 +10726,8 @@
           <a:chExt cx="0" cy="0"/>
         </a:xfrm>
       </p:grpSpPr>
-      <mc:AlternateContent xmlns:mc="http://schemas.openxmlformats.org/markup-compatibility/2006" xmlns:a14="http://schemas.microsoft.com/office/drawing/2010/main">
-        <mc:Choice Requires="a14">
+      <mc:AlternateContent xmlns:mc="http://schemas.openxmlformats.org/markup-compatibility/2006">
+        <mc:Choice xmlns:a14="http://schemas.microsoft.com/office/drawing/2010/main" Requires="a14">
           <p:sp>
             <p:nvSpPr>
               <p:cNvPr id="16" name="Content Placeholder 15">
@@ -10701,7 +10744,12 @@
                 <p:ph sz="half" idx="1"/>
               </p:nvPr>
             </p:nvSpPr>
-            <p:spPr/>
+            <p:spPr>
+              <a:xfrm>
+                <a:off x="711199" y="1295400"/>
+                <a:ext cx="7950861" cy="4819650"/>
+              </a:xfrm>
+            </p:spPr>
             <p:txBody>
               <a:bodyPr/>
               <a:lstStyle/>
@@ -10819,7 +10867,11 @@
                 </a:pPr>
                 <a:r>
                   <a:rPr lang="en-US" i="1" dirty="0"/>
-                  <a:t>		W</a:t>
+                  <a:t>W</a:t>
+                </a:r>
+                <a:r>
+                  <a:rPr lang="en-US" baseline="-25000" dirty="0"/>
+                  <a:t>1</a:t>
                 </a:r>
                 <a:r>
                   <a:rPr lang="en-US" dirty="0"/>
@@ -10830,14 +10882,38 @@
                   <a:t>B</a:t>
                 </a:r>
                 <a:r>
+                  <a:rPr lang="en-US" baseline="-25000" dirty="0"/>
+                  <a:t>1</a:t>
+                </a:r>
+                <a:r>
                   <a:rPr lang="en-US" dirty="0"/>
-                  <a:t> are learnable matrices.</a:t>
+                  <a:t> are matrices and </a:t>
                 </a:r>
+                <a14:m>
+                  <m:oMath xmlns:m="http://schemas.openxmlformats.org/officeDocument/2006/math">
+                    <m:r>
+                      <a:rPr lang="en-US" i="1">
+                        <a:latin typeface="Cambria Math" panose="02040503050406030204" pitchFamily="18" charset="0"/>
+                      </a:rPr>
+                      <m:t>𝜎</m:t>
+                    </m:r>
+                  </m:oMath>
+                </a14:m>
+                <a:r>
+                  <a:rPr lang="en-US" dirty="0"/>
+                  <a:t> a non-linear function.</a:t>
+                </a:r>
+              </a:p>
+              <a:p>
+                <a:pPr marL="0" indent="0">
+                  <a:buNone/>
+                </a:pPr>
+                <a:endParaRPr lang="en-US" dirty="0"/>
               </a:p>
             </p:txBody>
           </p:sp>
         </mc:Choice>
-        <mc:Fallback xmlns="">
+        <mc:Fallback>
           <p:sp>
             <p:nvSpPr>
               <p:cNvPr id="16" name="Content Placeholder 15">
@@ -10855,10 +10931,14 @@
               </p:nvPr>
             </p:nvSpPr>
             <p:spPr>
+              <a:xfrm>
+                <a:off x="711199" y="1295400"/>
+                <a:ext cx="7950861" cy="4819650"/>
+              </a:xfrm>
               <a:blipFill>
                 <a:blip r:embed="rId2"/>
                 <a:stretch>
-                  <a:fillRect l="-1309" t="-1316" b="-3684"/>
+                  <a:fillRect l="-1276" t="-1316" b="-3684"/>
                 </a:stretch>
               </a:blipFill>
             </p:spPr>
@@ -14648,8 +14728,8 @@
           <a:chExt cx="0" cy="0"/>
         </a:xfrm>
       </p:grpSpPr>
-      <mc:AlternateContent xmlns:mc="http://schemas.openxmlformats.org/markup-compatibility/2006" xmlns:a14="http://schemas.microsoft.com/office/drawing/2010/main">
-        <mc:Choice Requires="a14">
+      <mc:AlternateContent xmlns:mc="http://schemas.openxmlformats.org/markup-compatibility/2006">
+        <mc:Choice xmlns:a14="http://schemas.microsoft.com/office/drawing/2010/main" Requires="a14">
           <p:sp>
             <p:nvSpPr>
               <p:cNvPr id="5" name="Content Placeholder 4">
@@ -14676,7 +14756,7 @@
                 </a:pPr>
                 <a:r>
                   <a:rPr lang="en-US" dirty="0"/>
-                  <a:t>In this example, each edge is associated with a scalar:</a:t>
+                  <a:t>In our example, each edge is associated with a single scalar:</a:t>
                 </a:r>
               </a:p>
               <a:p>
@@ -15163,7 +15243,7 @@
             </p:txBody>
           </p:sp>
         </mc:Choice>
-        <mc:Fallback xmlns="">
+        <mc:Fallback>
           <p:sp>
             <p:nvSpPr>
               <p:cNvPr id="5" name="Content Placeholder 4">
@@ -15256,7 +15336,7 @@
         <p:spPr>
           <a:xfrm>
             <a:off x="2147480" y="4863803"/>
-            <a:ext cx="1814920" cy="461665"/>
+            <a:ext cx="2404826" cy="461665"/>
           </a:xfrm>
           <a:prstGeom prst="rect">
             <a:avLst/>
@@ -15271,7 +15351,7 @@
           <a:p>
             <a:r>
               <a:rPr lang="en-US" dirty="0"/>
-              <a:t>e</a:t>
+              <a:t>(16) e</a:t>
             </a:r>
             <a:r>
               <a:rPr lang="en-US" b="0" dirty="0"/>
@@ -17513,8 +17593,8 @@
           </a:effectLst>
         </p:spPr>
       </p:pic>
-      <mc:AlternateContent xmlns:mc="http://schemas.openxmlformats.org/markup-compatibility/2006" xmlns:a14="http://schemas.microsoft.com/office/drawing/2010/main">
-        <mc:Choice Requires="a14">
+      <mc:AlternateContent xmlns:mc="http://schemas.openxmlformats.org/markup-compatibility/2006">
+        <mc:Choice xmlns:a14="http://schemas.microsoft.com/office/drawing/2010/main" Requires="a14">
           <p:sp>
             <p:nvSpPr>
               <p:cNvPr id="16" name="Content Placeholder 15">
@@ -17623,6 +17703,33 @@
                 </a:r>
               </a:p>
               <a:p>
+                <a:endParaRPr lang="en-US" dirty="0"/>
+              </a:p>
+              <a:p>
+                <a:r>
+                  <a:rPr lang="en-US" dirty="0"/>
+                  <a:t>In more sophisticated GAEs, each </a:t>
+                </a:r>
+                <a:br>
+                  <a:rPr lang="en-US" dirty="0"/>
+                </a:br>
+                <a:r>
+                  <a:rPr lang="en-US" dirty="0"/>
+                  <a:t>edge is usually associated with </a:t>
+                </a:r>
+                <a:br>
+                  <a:rPr lang="en-US" dirty="0"/>
+                </a:br>
+                <a:r>
+                  <a:rPr lang="en-US" dirty="0"/>
+                  <a:t>several edge features.</a:t>
+                </a:r>
+                <a:br>
+                  <a:rPr lang="en-US" dirty="0"/>
+                </a:br>
+                <a:endParaRPr lang="en-US" dirty="0"/>
+              </a:p>
+              <a:p>
                 <a:pPr marL="0" indent="0">
                   <a:buNone/>
                 </a:pPr>
@@ -17631,7 +17738,7 @@
             </p:txBody>
           </p:sp>
         </mc:Choice>
-        <mc:Fallback xmlns="">
+        <mc:Fallback>
           <p:sp>
             <p:nvSpPr>
               <p:cNvPr id="16" name="Content Placeholder 15">
@@ -17794,8 +17901,8 @@
           </a:effectLst>
         </p:spPr>
       </p:pic>
-      <mc:AlternateContent xmlns:mc="http://schemas.openxmlformats.org/markup-compatibility/2006" xmlns:a14="http://schemas.microsoft.com/office/drawing/2010/main">
-        <mc:Choice Requires="a14">
+      <mc:AlternateContent xmlns:mc="http://schemas.openxmlformats.org/markup-compatibility/2006">
+        <mc:Choice xmlns:a14="http://schemas.microsoft.com/office/drawing/2010/main" Requires="a14">
           <p:sp>
             <p:nvSpPr>
               <p:cNvPr id="16" name="Content Placeholder 15">
@@ -17916,20 +18023,20 @@
                 </a:br>
                 <a:r>
                   <a:rPr lang="en-US" dirty="0"/>
-                  <a:t>related to source nodes 1 and 3 but </a:t>
+                  <a:t>related to itself and source nodes 1 </a:t>
                 </a:r>
                 <a:br>
                   <a:rPr lang="en-US" dirty="0"/>
                 </a:br>
                 <a:r>
                   <a:rPr lang="en-US" dirty="0"/>
-                  <a:t>not to source node 2.</a:t>
+                  <a:t>and 3 but not to source node 2.</a:t>
                 </a:r>
               </a:p>
             </p:txBody>
           </p:sp>
         </mc:Choice>
-        <mc:Fallback xmlns="">
+        <mc:Fallback>
           <p:sp>
             <p:nvSpPr>
               <p:cNvPr id="16" name="Content Placeholder 15">
@@ -19755,8 +19862,8 @@
           <a:chExt cx="0" cy="0"/>
         </a:xfrm>
       </p:grpSpPr>
-      <mc:AlternateContent xmlns:mc="http://schemas.openxmlformats.org/markup-compatibility/2006" xmlns:a14="http://schemas.microsoft.com/office/drawing/2010/main">
-        <mc:Choice Requires="a14">
+      <mc:AlternateContent xmlns:mc="http://schemas.openxmlformats.org/markup-compatibility/2006">
+        <mc:Choice xmlns:a14="http://schemas.microsoft.com/office/drawing/2010/main" Requires="a14">
           <p:sp>
             <p:nvSpPr>
               <p:cNvPr id="16" name="Content Placeholder 15">
@@ -19875,7 +19982,7 @@
                 </a14:m>
                 <a:r>
                   <a:rPr lang="en-US" dirty="0"/>
-                  <a:t> and focus on one target node (a row) and one column of </a:t>
+                  <a:t> and focus on one target node (a row) and one feature (a column) of </a:t>
                 </a:r>
                 <a14:m>
                   <m:oMath xmlns:m="http://schemas.openxmlformats.org/officeDocument/2006/math">
@@ -19920,7 +20027,7 @@
                   <a:t>a </a:t>
                 </a:r>
                 <a:r>
-                  <a:rPr lang="en-US" b="1" dirty="0">
+                  <a:rPr lang="en-US" dirty="0">
                     <a:solidFill>
                       <a:srgbClr val="0033CC"/>
                     </a:solidFill>
@@ -19953,14 +20060,14 @@
                 </a14:m>
                 <a:r>
                   <a:rPr lang="en-US" dirty="0"/>
-                  <a:t> (which corresponds to an </a:t>
+                  <a:t> (which, as noted, corresponds to </a:t>
                 </a:r>
                 <a:br>
                   <a:rPr lang="en-US" dirty="0"/>
                 </a:br>
                 <a:r>
                   <a:rPr lang="en-US" dirty="0"/>
-                  <a:t>embedded feature) and each row of</a:t>
+                  <a:t>an embedded feature) and each row of</a:t>
                 </a:r>
                 <a:br>
                   <a:rPr lang="en-US" dirty="0"/>
@@ -20040,7 +20147,7 @@
             </p:txBody>
           </p:sp>
         </mc:Choice>
-        <mc:Fallback xmlns="">
+        <mc:Fallback>
           <p:sp>
             <p:nvSpPr>
               <p:cNvPr id="16" name="Content Placeholder 15">
@@ -23798,8 +23905,8 @@
           <a:chExt cx="0" cy="0"/>
         </a:xfrm>
       </p:grpSpPr>
-      <mc:AlternateContent xmlns:mc="http://schemas.openxmlformats.org/markup-compatibility/2006" xmlns:a14="http://schemas.microsoft.com/office/drawing/2010/main">
-        <mc:Choice Requires="a14">
+      <mc:AlternateContent xmlns:mc="http://schemas.openxmlformats.org/markup-compatibility/2006">
+        <mc:Choice xmlns:a14="http://schemas.microsoft.com/office/drawing/2010/main" Requires="a14">
           <p:sp>
             <p:nvSpPr>
               <p:cNvPr id="8" name="Content Placeholder 7">
@@ -23970,7 +24077,7 @@
               <a:p>
                 <a:r>
                   <a:rPr lang="en-US" dirty="0"/>
-                  <a:t>Here is </a:t>
+                  <a:t>Here is a </a:t>
                 </a:r>
                 <a:r>
                   <a:rPr lang="en-US" b="1" dirty="0">
@@ -24006,7 +24113,7 @@
                 </a:r>
                 <a:r>
                   <a:rPr lang="en-US" dirty="0"/>
-                  <a:t> edges.</a:t>
+                  <a:t> edges*.</a:t>
                 </a:r>
               </a:p>
               <a:p>
@@ -24050,12 +24157,20 @@
                 <a:pPr marL="0" indent="0">
                   <a:buNone/>
                 </a:pPr>
+                <a:r>
+                  <a:rPr lang="en-US" dirty="0"/>
+                  <a:t>* </a:t>
+                </a:r>
+                <a:r>
+                  <a:rPr lang="en-US" sz="2000" dirty="0"/>
+                  <a:t>6 of the edges are doubled.</a:t>
+                </a:r>
                 <a:endParaRPr lang="en-US" dirty="0"/>
               </a:p>
             </p:txBody>
           </p:sp>
         </mc:Choice>
-        <mc:Fallback xmlns="">
+        <mc:Fallback>
           <p:sp>
             <p:nvSpPr>
               <p:cNvPr id="8" name="Content Placeholder 7">
@@ -24076,7 +24191,7 @@
               <a:blipFill>
                 <a:blip r:embed="rId2"/>
                 <a:stretch>
-                  <a:fillRect l="-1146" t="-1316"/>
+                  <a:fillRect l="-1309" t="-1316" b="-3684"/>
                 </a:stretch>
               </a:blipFill>
             </p:spPr>
@@ -33123,7 +33238,12 @@
             <p:ph sz="half" idx="1"/>
           </p:nvPr>
         </p:nvSpPr>
-        <p:spPr/>
+        <p:spPr>
+          <a:xfrm>
+            <a:off x="711200" y="1295400"/>
+            <a:ext cx="7960710" cy="4819650"/>
+          </a:xfrm>
+        </p:spPr>
         <p:txBody>
           <a:bodyPr/>
           <a:lstStyle/>
@@ -33166,7 +33286,7 @@
             </a:r>
             <a:r>
               <a:rPr lang="en-US" dirty="0"/>
-              <a:t> the latent space representation of the graph back to the original graph.</a:t>
+              <a:t> the latent space representation of the graph back to a graph, e.g., the original.</a:t>
             </a:r>
           </a:p>
           <a:p>
@@ -33187,7 +33307,7 @@
           <a:p>
             <a:r>
               <a:rPr lang="en-US" dirty="0"/>
-              <a:t>A typical application is detecting anomalies in a graph: if a GAE fails to reconstruct the input graph correctly, this may indicate an anomaly. However, that this claim has recently been called into question</a:t>
+              <a:t>A typical application is detecting anomalies in a graph: if a GAE fails to reconstruct the input graph correctly, this may indicate an anomaly. However, this claim has recently been called into question</a:t>
             </a:r>
             <a:r>
               <a:rPr lang="en-US" baseline="30000" dirty="0"/>

</xml_diff>